<commit_message>
Say "source", not "feed", everywhere a person reads
Venu's vocabulary, via Arjun: the unit the code calls Feed is a "source"
in the app's UI strings, the three decks (regenerated), the screens
catalogue script, the stage-03 report header and 04's provenance notes.
Code identifiers, the contract JSON, contract_name and the id-hashed
ambiguity texts are deliberately unchanged.

Co-Authored-By: Claude Fable 5 <noreply@anthropic.com>
</commit_message>
<xml_diff>
--- a/context/FRD-and-Dictionary-Input-Requirements.pptx
+++ b/context/FRD-and-Dictionary-Input-Requirements.pptx
@@ -550,7 +550,7 @@
           </a:p>
           <a:p>
             <a:r>
-              <a:t>feed-level frame and raises one gated question naming the file whose columns it</a:t>
+              <a:t>source-level frame and raises one gated question naming the file whose columns it</a:t>
             </a:r>
           </a:p>
           <a:p>
@@ -852,7 +852,7 @@
           </a:p>
           <a:p>
             <a:r>
-              <a:t>The worked case: one real feed is a headerless, pipe-delimited file carrying three</a:t>
+              <a:t>The worked case: one real source is a headerless, pipe-delimited file carrying three</a:t>
             </a:r>
           </a:p>
           <a:p>
@@ -904,7 +904,7 @@
           </a:p>
           <a:p>
             <a:r>
-              <a:t>supplies. The agent decides from the FRD ALONE whether a feed renames: if the</a:t>
+              <a:t>supplies. The agent decides from the FRD ALONE whether a source renames: if the</a:t>
             </a:r>
           </a:p>
           <a:p>
@@ -914,13 +914,13 @@
           </a:p>
           <a:p>
             <a:r>
-              <a:t>on both real feeds (CAQH renames 115/115, SD 4/411).</a:t>
+              <a:t>on both real sources (CAQH renames 115/115, SD 4/411).</a:t>
             </a:r>
           </a:p>
           <a:p/>
           <a:p>
             <a:r>
-              <a:t>What the reviewer then receives, on the renaming feed: 22 of 115 exact, 63 more</a:t>
+              <a:t>What the reviewer then receives, on the renaming source: 22 of 115 exact, 63 more</a:t>
             </a:r>
           </a:p>
           <a:p>
@@ -945,7 +945,7 @@
           </a:p>
           <a:p>
             <a:r>
-              <a:t>workbook. On a feed that does not rename, the agent is at 388/391.</a:t>
+              <a:t>workbook. On a source that does not rename, the agent is at 388/391.</a:t>
             </a:r>
           </a:p>
           <a:p/>
@@ -4419,7 +4419,7 @@
                 </a:solidFill>
                 <a:latin typeface="Segoe UI"/>
               </a:rPr>
-              <a:t>the feed-level frame</a:t>
+              <a:t>the source-level frame</a:t>
             </a:r>
           </a:p>
         </p:txBody>
@@ -5857,7 +5857,7 @@
                 </a:solidFill>
                 <a:latin typeface="Segoe UI"/>
               </a:rPr>
-              <a:t> — the warehouse's own column vocabulary, harvested from approved STTMs when they sync. Nobody attaches either to a feed, and </a:t>
+              <a:t> — the warehouse's own column vocabulary, harvested from approved STTMs when they sync. Nobody attaches either to a source, and </a:t>
             </a:r>
             <a:r>
               <a:rPr sz="1000" b="1">
@@ -6042,7 +6042,7 @@
                 </a:solidFill>
                 <a:latin typeface="Consolas"/>
               </a:rPr>
-              <a:t>VDD_&lt;feed&gt;.xlsx</a:t>
+              <a:t>VDD_&lt;source&gt;.xlsx</a:t>
             </a:r>
             <a:r>
               <a:rPr sz="1100" b="0">
@@ -6060,7 +6060,7 @@
                 </a:solidFill>
                 <a:latin typeface="Consolas"/>
               </a:rPr>
-              <a:t>FRD_&lt;feed&gt;.docx</a:t>
+              <a:t>FRD_&lt;source&gt;.docx</a:t>
             </a:r>
             <a:r>
               <a:rPr sz="1100" b="0">
@@ -7753,7 +7753,7 @@
                 </a:solidFill>
                 <a:latin typeface="Segoe UI"/>
               </a:rPr>
-              <a:t>Out of scope for an ingest feed</a:t>
+              <a:t>Out of scope for an ingest source</a:t>
             </a:r>
           </a:p>
         </p:txBody>
@@ -8185,7 +8185,7 @@
                 </a:solidFill>
                 <a:latin typeface="Consolas"/>
               </a:rPr>
-              <a:t>Name the VDD_&lt;feed&gt;.xlsx here</a:t>
+              <a:t>Name the VDD_&lt;source&gt;.xlsx here</a:t>
             </a:r>
           </a:p>
         </p:txBody>
@@ -8987,7 +8987,7 @@
                 </a:solidFill>
                 <a:latin typeface="Segoe UI"/>
               </a:rPr>
-              <a:t>One Excel workbook per feed, two kinds of sheet. Nothing in it is an ACFC decision — every cell is something the vendor already knows about its own file.</a:t>
+              <a:t>One Excel workbook per source, two kinds of sheet. Nothing in it is an ACFC decision — every cell is something the vendor already knows about its own file.</a:t>
             </a:r>
           </a:p>
         </p:txBody>
@@ -9288,7 +9288,7 @@
                 </a:solidFill>
                 <a:latin typeface="Segoe UI"/>
               </a:rPr>
-              <a:t>matches a delivered file to this feed</a:t>
+              <a:t>matches a delivered file to this source</a:t>
             </a:r>
           </a:p>
         </p:txBody>
@@ -12040,7 +12040,7 @@
                 </a:solidFill>
                 <a:latin typeface="Segoe UI"/>
               </a:rPr>
-              <a:t>templates/DICT_TEMPLATE_v1.3.xlsx — issue it to the vendor as-is; src/frdsttm/dictionary.py parses what comes back</a:t>
+              <a:t>templates/DICT_TEMPLATE.xlsx — issue it to the vendor as-is; src/frdsttm/dictionary.py parses what comes back</a:t>
             </a:r>
           </a:p>
         </p:txBody>

</xml_diff>